<commit_message>
Apply GCTU student details to deliverables
</commit_message>
<xml_diff>
--- a/docs/presentation/traffic-light-demo-corrected.pptx
+++ b/docs/presentation/traffic-light-demo-corrected.pptx
@@ -2,23 +2,23 @@
 <file path=ppt/presentation.xml><?xml version="1.0" encoding="utf-8"?>
 <p:presentation xmlns:p="http://schemas.openxmlformats.org/presentationml/2006/main">
   <p:sldMasterIdLst>
-    <p:sldMasterId xmlns:r="http://schemas.openxmlformats.org/officeDocument/2006/relationships" id="2147483648" r:id="R472926602004495d"/>
+    <p:sldMasterId xmlns:r="http://schemas.openxmlformats.org/officeDocument/2006/relationships" id="2147483648" r:id="Raa950d69b44648f4"/>
   </p:sldMasterIdLst>
   <p:notesMasterIdLst>
-    <p:notesMasterId xmlns:r="http://schemas.openxmlformats.org/officeDocument/2006/relationships" r:id="Re298c223113045e7"/>
+    <p:notesMasterId xmlns:r="http://schemas.openxmlformats.org/officeDocument/2006/relationships" r:id="Rff16ba4140774159"/>
   </p:notesMasterIdLst>
   <p:sldIdLst>
-    <p:sldId xmlns:r="http://schemas.openxmlformats.org/officeDocument/2006/relationships" id="256" r:id="Rfe9885921a134df3"/>
-    <p:sldId xmlns:r="http://schemas.openxmlformats.org/officeDocument/2006/relationships" id="257" r:id="R5d7a2642503347fc"/>
-    <p:sldId xmlns:r="http://schemas.openxmlformats.org/officeDocument/2006/relationships" id="258" r:id="R8b4a5aaf36514c0f"/>
-    <p:sldId xmlns:r="http://schemas.openxmlformats.org/officeDocument/2006/relationships" id="259" r:id="Re529f7990e4e48da"/>
-    <p:sldId xmlns:r="http://schemas.openxmlformats.org/officeDocument/2006/relationships" id="260" r:id="R3bfb588995f74a7e"/>
-    <p:sldId xmlns:r="http://schemas.openxmlformats.org/officeDocument/2006/relationships" id="261" r:id="R3488ee3af8a04b1b"/>
-    <p:sldId xmlns:r="http://schemas.openxmlformats.org/officeDocument/2006/relationships" id="262" r:id="Rf38193ca5a034b86"/>
-    <p:sldId xmlns:r="http://schemas.openxmlformats.org/officeDocument/2006/relationships" id="263" r:id="Reda662438510448a"/>
-    <p:sldId xmlns:r="http://schemas.openxmlformats.org/officeDocument/2006/relationships" id="264" r:id="Rdefae9dcd47d470c"/>
-    <p:sldId xmlns:r="http://schemas.openxmlformats.org/officeDocument/2006/relationships" id="265" r:id="R6eb168eead484156"/>
-    <p:sldId xmlns:r="http://schemas.openxmlformats.org/officeDocument/2006/relationships" id="266" r:id="R7f07c43ea55f4b09"/>
+    <p:sldId xmlns:r="http://schemas.openxmlformats.org/officeDocument/2006/relationships" id="256" r:id="R45b793490a4f446a"/>
+    <p:sldId xmlns:r="http://schemas.openxmlformats.org/officeDocument/2006/relationships" id="257" r:id="R009a35cf55994f71"/>
+    <p:sldId xmlns:r="http://schemas.openxmlformats.org/officeDocument/2006/relationships" id="258" r:id="Rf31f0598e67b4dde"/>
+    <p:sldId xmlns:r="http://schemas.openxmlformats.org/officeDocument/2006/relationships" id="259" r:id="R18ef3c73b44a4f87"/>
+    <p:sldId xmlns:r="http://schemas.openxmlformats.org/officeDocument/2006/relationships" id="260" r:id="Rbf0c5193fd454bb1"/>
+    <p:sldId xmlns:r="http://schemas.openxmlformats.org/officeDocument/2006/relationships" id="261" r:id="R96e70ebe51fc44ea"/>
+    <p:sldId xmlns:r="http://schemas.openxmlformats.org/officeDocument/2006/relationships" id="262" r:id="R5d6808bbedcf4fd2"/>
+    <p:sldId xmlns:r="http://schemas.openxmlformats.org/officeDocument/2006/relationships" id="263" r:id="Rda41465dcbd5457e"/>
+    <p:sldId xmlns:r="http://schemas.openxmlformats.org/officeDocument/2006/relationships" id="264" r:id="R4a62bf5b2ae3495d"/>
+    <p:sldId xmlns:r="http://schemas.openxmlformats.org/officeDocument/2006/relationships" id="265" r:id="R972992a79f294775"/>
+    <p:sldId xmlns:r="http://schemas.openxmlformats.org/officeDocument/2006/relationships" id="266" r:id="R58e4d30142bf4a0f"/>
   </p:sldIdLst>
   <p:sldSz cx="12192000" cy="6858000"/>
   <p:notesSz cx="6858000" cy="9144000"/>
@@ -1220,7 +1220,7 @@
   </p:cSld>
   <p:clrMap bg1="lt1" tx1="dk1" bg2="lt2" tx2="dk2" accent1="accent1" accent2="accent2" accent3="accent3" accent4="accent4" accent5="accent5" accent6="accent6" hlink="hlink" folHlink="folHlink"/>
   <p:sldLayoutIdLst>
-    <p:sldLayoutId xmlns:r="http://schemas.openxmlformats.org/officeDocument/2006/relationships" id="2147483649" r:id="Rf2b2172a33d54cb8"/>
+    <p:sldLayoutId xmlns:r="http://schemas.openxmlformats.org/officeDocument/2006/relationships" id="2147483649" r:id="R4893ce43893b4d9c"/>
   </p:sldLayoutIdLst>
   <p:txStyles>
     <p:titleStyle>
@@ -2074,10 +2074,10 @@
       </p:grpSpPr>
       <p:sp>
         <p:nvSpPr>
-          <p:cNvPr id="6" name="">
+          <p:cNvPr id="11" name="">
             <a:extLst xmlns:a="http://schemas.openxmlformats.org/drawingml/2006/main">
               <a:ext uri="{FF2B5EF4-FFF2-40B4-BE49-F238E27FC236}">
-                <a16:creationId xmlns:a16="http://schemas.microsoft.com/office/drawing/2014/main" id="{EE5D98E0-B029-45EB-9420-BEBF15F9E918}"/>
+                <a16:creationId xmlns:a16="http://schemas.microsoft.com/office/drawing/2014/main" id="{6B4D84F0-9178-47D9-8BFB-C0472B50A6C0}"/>
               </a:ext>
             </a:extLst>
           </p:cNvPr>
@@ -2088,8 +2088,8 @@
         </p:nvSpPr>
         <p:spPr>
           <a:xfrm xmlns:a="http://schemas.openxmlformats.org/drawingml/2006/main">
-            <a:off x="704850" y="1104900"/>
-            <a:ext cx="7239000" cy="1619250"/>
+            <a:off x="704850" y="533400"/>
+            <a:ext cx="7239000" cy="285750"/>
           </a:xfrm>
           <a:prstGeom xmlns:a="http://schemas.openxmlformats.org/drawingml/2006/main" prst="rect">
             <a:avLst/>
@@ -2106,7 +2106,7 @@
           <a:lstStyle xmlns:a="http://schemas.openxmlformats.org/drawingml/2006/main"/>
           <a:p xmlns:a="http://schemas.openxmlformats.org/drawingml/2006/main">
             <a:pPr algn="l">
-              <a:defRPr sz="3150" b="1">
+              <a:defRPr sz="1275" b="1">
                 <a:solidFill>
                   <a:srgbClr val="17202A"/>
                 </a:solidFill>
@@ -2116,7 +2116,7 @@
               </a:defRPr>
             </a:pPr>
             <a:r>
-              <a:rPr sz="3150" b="1">
+              <a:rPr sz="1275" b="1">
                 <a:solidFill>
                   <a:srgbClr val="17202A"/>
                 </a:solidFill>
@@ -2124,7 +2124,7 @@
                 <a:ea typeface="Arial"/>
                 <a:cs typeface="Arial"/>
               </a:rPr>
-              <a:t>Design and Evaluation of a Simulation-Based Adaptive Smart Traffic-Light Controller</a:t>
+              <a:t>GHANA COMMUNICATION TECHNOLOGY UNIVERSITY (GCTU)</a:t>
             </a:r>
           </a:p>
         </p:txBody>
@@ -2134,7 +2134,7 @@
           <p:cNvPr id="2" name="">
             <a:extLst xmlns:a="http://schemas.openxmlformats.org/drawingml/2006/main">
               <a:ext uri="{FF2B5EF4-FFF2-40B4-BE49-F238E27FC236}">
-                <a16:creationId xmlns:a16="http://schemas.microsoft.com/office/drawing/2014/main" id="{CBF5B78D-6E01-4B59-ADC8-68A84137CB92}"/>
+                <a16:creationId xmlns:a16="http://schemas.microsoft.com/office/drawing/2014/main" id="{8E4F81FC-5852-48AC-AC12-CA2E2012D985}"/>
               </a:ext>
             </a:extLst>
           </p:cNvPr>
@@ -2145,8 +2145,8 @@
         </p:nvSpPr>
         <p:spPr>
           <a:xfrm xmlns:a="http://schemas.openxmlformats.org/drawingml/2006/main">
-            <a:off x="742950" y="2933700"/>
-            <a:ext cx="5334000" cy="342900"/>
+            <a:off x="704850" y="838200"/>
+            <a:ext cx="7239000" cy="266700"/>
           </a:xfrm>
           <a:prstGeom xmlns:a="http://schemas.openxmlformats.org/drawingml/2006/main" prst="rect">
             <a:avLst/>
@@ -2163,7 +2163,7 @@
           <a:lstStyle xmlns:a="http://schemas.openxmlformats.org/drawingml/2006/main"/>
           <a:p xmlns:a="http://schemas.openxmlformats.org/drawingml/2006/main">
             <a:pPr algn="l">
-              <a:defRPr sz="1575" b="0">
+              <a:defRPr sz="975" b="0">
                 <a:solidFill>
                   <a:srgbClr val="637083"/>
                 </a:solidFill>
@@ -2173,7 +2173,7 @@
               </a:defRPr>
             </a:pPr>
             <a:r>
-              <a:rPr sz="1575" b="0">
+              <a:rPr sz="975" b="0">
                 <a:solidFill>
                   <a:srgbClr val="637083"/>
                 </a:solidFill>
@@ -2181,7 +2181,7 @@
                 <a:ea typeface="Arial"/>
                 <a:cs typeface="Arial"/>
               </a:rPr>
-              <a:t>Final-year project demonstration</a:t>
+              <a:t>FACULTY OF ENGINEERING | DEPARTMENT OF COMPUTER ENGINEERING</a:t>
             </a:r>
           </a:p>
         </p:txBody>
@@ -2191,7 +2191,7 @@
           <p:cNvPr id="3" name="">
             <a:extLst xmlns:a="http://schemas.openxmlformats.org/drawingml/2006/main">
               <a:ext uri="{FF2B5EF4-FFF2-40B4-BE49-F238E27FC236}">
-                <a16:creationId xmlns:a16="http://schemas.microsoft.com/office/drawing/2014/main" id="{7E2A6BF9-9BD7-47A1-8256-65AB6B4E63CF}"/>
+                <a16:creationId xmlns:a16="http://schemas.microsoft.com/office/drawing/2014/main" id="{101C53A8-CB51-40E9-A2E1-D5EC455130B7}"/>
               </a:ext>
             </a:extLst>
           </p:cNvPr>
@@ -2202,8 +2202,8 @@
         </p:nvSpPr>
         <p:spPr>
           <a:xfrm xmlns:a="http://schemas.openxmlformats.org/drawingml/2006/main">
-            <a:off x="742950" y="3371850"/>
-            <a:ext cx="6191250" cy="323850"/>
+            <a:off x="704850" y="1352550"/>
+            <a:ext cx="7239000" cy="1352550"/>
           </a:xfrm>
           <a:prstGeom xmlns:a="http://schemas.openxmlformats.org/drawingml/2006/main" prst="rect">
             <a:avLst/>
@@ -2220,9 +2220,9 @@
           <a:lstStyle xmlns:a="http://schemas.openxmlformats.org/drawingml/2006/main"/>
           <a:p xmlns:a="http://schemas.openxmlformats.org/drawingml/2006/main">
             <a:pPr algn="l">
-              <a:defRPr sz="1350" b="0">
-                <a:solidFill>
-                  <a:srgbClr val="1F6FEB"/>
+              <a:defRPr sz="2850" b="1">
+                <a:solidFill>
+                  <a:srgbClr val="17202A"/>
                 </a:solidFill>
                 <a:latin typeface="Arial"/>
                 <a:ea typeface="Arial"/>
@@ -2230,7 +2230,121 @@
               </a:defRPr>
             </a:pPr>
             <a:r>
-              <a:rPr sz="1350" b="0">
+              <a:rPr sz="2850" b="1">
+                <a:solidFill>
+                  <a:srgbClr val="17202A"/>
+                </a:solidFill>
+                <a:latin typeface="Arial"/>
+                <a:ea typeface="Arial"/>
+                <a:cs typeface="Arial"/>
+              </a:rPr>
+              <a:t>Design and Evaluation of a Simulation-Based Adaptive Smart Traffic-Light Controller</a:t>
+            </a:r>
+          </a:p>
+        </p:txBody>
+      </p:sp>
+      <p:sp>
+        <p:nvSpPr>
+          <p:cNvPr id="4" name="">
+            <a:extLst xmlns:a="http://schemas.openxmlformats.org/drawingml/2006/main">
+              <a:ext uri="{FF2B5EF4-FFF2-40B4-BE49-F238E27FC236}">
+                <a16:creationId xmlns:a16="http://schemas.microsoft.com/office/drawing/2014/main" id="{60AEA265-5118-4230-B464-6557B3A7B2A4}"/>
+              </a:ext>
+            </a:extLst>
+          </p:cNvPr>
+          <p:cNvSpPr>
+            <a:spLocks xmlns:a="http://schemas.openxmlformats.org/drawingml/2006/main" noGrp="1"/>
+          </p:cNvSpPr>
+          <p:nvPr/>
+        </p:nvSpPr>
+        <p:spPr>
+          <a:xfrm xmlns:a="http://schemas.openxmlformats.org/drawingml/2006/main">
+            <a:off x="742950" y="2876550"/>
+            <a:ext cx="5334000" cy="323850"/>
+          </a:xfrm>
+          <a:prstGeom xmlns:a="http://schemas.openxmlformats.org/drawingml/2006/main" prst="rect">
+            <a:avLst/>
+          </a:prstGeom>
+          <a:noFill xmlns:a="http://schemas.openxmlformats.org/drawingml/2006/main"/>
+          <a:ln xmlns:a="http://schemas.openxmlformats.org/drawingml/2006/main" w="0">
+            <a:noFill/>
+          </a:ln>
+        </p:spPr>
+        <p:txBody>
+          <a:bodyPr xmlns:a="http://schemas.openxmlformats.org/drawingml/2006/main">
+            <a:noAutofit/>
+          </a:bodyPr>
+          <a:lstStyle xmlns:a="http://schemas.openxmlformats.org/drawingml/2006/main"/>
+          <a:p xmlns:a="http://schemas.openxmlformats.org/drawingml/2006/main">
+            <a:pPr algn="l">
+              <a:defRPr sz="1500" b="0">
+                <a:solidFill>
+                  <a:srgbClr val="637083"/>
+                </a:solidFill>
+                <a:latin typeface="Arial"/>
+                <a:ea typeface="Arial"/>
+                <a:cs typeface="Arial"/>
+              </a:defRPr>
+            </a:pPr>
+            <a:r>
+              <a:rPr sz="1500" b="0">
+                <a:solidFill>
+                  <a:srgbClr val="637083"/>
+                </a:solidFill>
+                <a:latin typeface="Arial"/>
+                <a:ea typeface="Arial"/>
+                <a:cs typeface="Arial"/>
+              </a:rPr>
+              <a:t>Final-year project demonstration</a:t>
+            </a:r>
+          </a:p>
+        </p:txBody>
+      </p:sp>
+      <p:sp>
+        <p:nvSpPr>
+          <p:cNvPr id="5" name="">
+            <a:extLst xmlns:a="http://schemas.openxmlformats.org/drawingml/2006/main">
+              <a:ext uri="{FF2B5EF4-FFF2-40B4-BE49-F238E27FC236}">
+                <a16:creationId xmlns:a16="http://schemas.microsoft.com/office/drawing/2014/main" id="{34EF8945-90B4-4D9B-AA0D-A5DAE9156AFC}"/>
+              </a:ext>
+            </a:extLst>
+          </p:cNvPr>
+          <p:cNvSpPr>
+            <a:spLocks xmlns:a="http://schemas.openxmlformats.org/drawingml/2006/main" noGrp="1"/>
+          </p:cNvSpPr>
+          <p:nvPr/>
+        </p:nvSpPr>
+        <p:spPr>
+          <a:xfrm xmlns:a="http://schemas.openxmlformats.org/drawingml/2006/main">
+            <a:off x="742950" y="3276600"/>
+            <a:ext cx="6191250" cy="304800"/>
+          </a:xfrm>
+          <a:prstGeom xmlns:a="http://schemas.openxmlformats.org/drawingml/2006/main" prst="rect">
+            <a:avLst/>
+          </a:prstGeom>
+          <a:noFill xmlns:a="http://schemas.openxmlformats.org/drawingml/2006/main"/>
+          <a:ln xmlns:a="http://schemas.openxmlformats.org/drawingml/2006/main" w="0">
+            <a:noFill/>
+          </a:ln>
+        </p:spPr>
+        <p:txBody>
+          <a:bodyPr xmlns:a="http://schemas.openxmlformats.org/drawingml/2006/main">
+            <a:noAutofit/>
+          </a:bodyPr>
+          <a:lstStyle xmlns:a="http://schemas.openxmlformats.org/drawingml/2006/main"/>
+          <a:p xmlns:a="http://schemas.openxmlformats.org/drawingml/2006/main">
+            <a:pPr algn="l">
+              <a:defRPr sz="1275" b="0">
+                <a:solidFill>
+                  <a:srgbClr val="1F6FEB"/>
+                </a:solidFill>
+                <a:latin typeface="Arial"/>
+                <a:ea typeface="Arial"/>
+                <a:cs typeface="Arial"/>
+              </a:defRPr>
+            </a:pPr>
+            <a:r>
+              <a:rPr sz="1275" b="0">
                 <a:solidFill>
                   <a:srgbClr val="1F6FEB"/>
                 </a:solidFill>
@@ -2243,17 +2357,211 @@
           </a:p>
         </p:txBody>
       </p:sp>
+      <p:sp>
+        <p:nvSpPr>
+          <p:cNvPr id="6" name="">
+            <a:extLst xmlns:a="http://schemas.openxmlformats.org/drawingml/2006/main">
+              <a:ext uri="{FF2B5EF4-FFF2-40B4-BE49-F238E27FC236}">
+                <a16:creationId xmlns:a16="http://schemas.microsoft.com/office/drawing/2014/main" id="{C68B1A77-40FF-461B-BD63-EBC6243AA0E8}"/>
+              </a:ext>
+            </a:extLst>
+          </p:cNvPr>
+          <p:cNvSpPr>
+            <a:spLocks xmlns:a="http://schemas.openxmlformats.org/drawingml/2006/main" noGrp="1"/>
+          </p:cNvSpPr>
+          <p:nvPr/>
+        </p:nvSpPr>
+        <p:spPr>
+          <a:xfrm xmlns:a="http://schemas.openxmlformats.org/drawingml/2006/main">
+            <a:off x="742950" y="3962400"/>
+            <a:ext cx="762000" cy="228600"/>
+          </a:xfrm>
+          <a:prstGeom xmlns:a="http://schemas.openxmlformats.org/drawingml/2006/main" prst="rect">
+            <a:avLst/>
+          </a:prstGeom>
+          <a:noFill xmlns:a="http://schemas.openxmlformats.org/drawingml/2006/main"/>
+          <a:ln xmlns:a="http://schemas.openxmlformats.org/drawingml/2006/main" w="0">
+            <a:noFill/>
+          </a:ln>
+        </p:spPr>
+        <p:txBody>
+          <a:bodyPr xmlns:a="http://schemas.openxmlformats.org/drawingml/2006/main">
+            <a:noAutofit/>
+          </a:bodyPr>
+          <a:lstStyle xmlns:a="http://schemas.openxmlformats.org/drawingml/2006/main"/>
+          <a:p xmlns:a="http://schemas.openxmlformats.org/drawingml/2006/main">
+            <a:pPr algn="l">
+              <a:defRPr sz="975" b="1">
+                <a:solidFill>
+                  <a:srgbClr val="17202A"/>
+                </a:solidFill>
+                <a:latin typeface="Arial"/>
+                <a:ea typeface="Arial"/>
+                <a:cs typeface="Arial"/>
+              </a:defRPr>
+            </a:pPr>
+            <a:r>
+              <a:rPr sz="975" b="1">
+                <a:solidFill>
+                  <a:srgbClr val="17202A"/>
+                </a:solidFill>
+                <a:latin typeface="Arial"/>
+                <a:ea typeface="Arial"/>
+                <a:cs typeface="Arial"/>
+              </a:rPr>
+              <a:t>BY:</a:t>
+            </a:r>
+          </a:p>
+        </p:txBody>
+      </p:sp>
+      <p:sp>
+        <p:nvSpPr>
+          <p:cNvPr id="7" name="">
+            <a:extLst xmlns:a="http://schemas.openxmlformats.org/drawingml/2006/main">
+              <a:ext uri="{FF2B5EF4-FFF2-40B4-BE49-F238E27FC236}">
+                <a16:creationId xmlns:a16="http://schemas.microsoft.com/office/drawing/2014/main" id="{1625A9B1-F5E9-4311-BCFE-1444F35D03E9}"/>
+              </a:ext>
+            </a:extLst>
+          </p:cNvPr>
+          <p:cNvSpPr>
+            <a:spLocks xmlns:a="http://schemas.openxmlformats.org/drawingml/2006/main" noGrp="1"/>
+          </p:cNvSpPr>
+          <p:nvPr/>
+        </p:nvSpPr>
+        <p:spPr>
+          <a:xfrm xmlns:a="http://schemas.openxmlformats.org/drawingml/2006/main">
+            <a:off x="742950" y="4210050"/>
+            <a:ext cx="4953000" cy="552450"/>
+          </a:xfrm>
+          <a:prstGeom xmlns:a="http://schemas.openxmlformats.org/drawingml/2006/main" prst="rect">
+            <a:avLst/>
+          </a:prstGeom>
+          <a:noFill xmlns:a="http://schemas.openxmlformats.org/drawingml/2006/main"/>
+          <a:ln xmlns:a="http://schemas.openxmlformats.org/drawingml/2006/main" w="0">
+            <a:noFill/>
+          </a:ln>
+        </p:spPr>
+        <p:txBody>
+          <a:bodyPr xmlns:a="http://schemas.openxmlformats.org/drawingml/2006/main">
+            <a:noAutofit/>
+          </a:bodyPr>
+          <a:lstStyle xmlns:a="http://schemas.openxmlformats.org/drawingml/2006/main"/>
+          <a:p xmlns:a="http://schemas.openxmlformats.org/drawingml/2006/main">
+            <a:pPr algn="l">
+              <a:defRPr sz="1125" b="0">
+                <a:solidFill>
+                  <a:srgbClr val="17202A"/>
+                </a:solidFill>
+                <a:latin typeface="Arial"/>
+                <a:ea typeface="Arial"/>
+                <a:cs typeface="Arial"/>
+              </a:defRPr>
+            </a:pPr>
+            <a:r>
+              <a:rPr sz="1125" b="0">
+                <a:solidFill>
+                  <a:srgbClr val="17202A"/>
+                </a:solidFill>
+                <a:latin typeface="Arial"/>
+                <a:ea typeface="Arial"/>
+                <a:cs typeface="Arial"/>
+              </a:rPr>
+              <a:t>HENYO THEOPHILUS - ID 4121230031</a:t>
+            </a:r>
+          </a:p>
+          <a:p xmlns:a="http://schemas.openxmlformats.org/drawingml/2006/main">
+            <a:pPr algn="l">
+              <a:defRPr sz="1125" b="0">
+                <a:solidFill>
+                  <a:srgbClr val="17202A"/>
+                </a:solidFill>
+                <a:latin typeface="Arial"/>
+                <a:ea typeface="Arial"/>
+                <a:cs typeface="Arial"/>
+              </a:defRPr>
+            </a:pPr>
+            <a:r>
+              <a:rPr sz="1125" b="0">
+                <a:solidFill>
+                  <a:srgbClr val="17202A"/>
+                </a:solidFill>
+                <a:latin typeface="Arial"/>
+                <a:ea typeface="Arial"/>
+                <a:cs typeface="Arial"/>
+              </a:rPr>
+              <a:t>DJAGNI JERRY KODJO - ID 4121230036</a:t>
+            </a:r>
+          </a:p>
+        </p:txBody>
+      </p:sp>
+      <p:sp>
+        <p:nvSpPr>
+          <p:cNvPr id="8" name="">
+            <a:extLst xmlns:a="http://schemas.openxmlformats.org/drawingml/2006/main">
+              <a:ext uri="{FF2B5EF4-FFF2-40B4-BE49-F238E27FC236}">
+                <a16:creationId xmlns:a16="http://schemas.microsoft.com/office/drawing/2014/main" id="{73DDC963-048E-4E21-B170-A43A86B5C6E2}"/>
+              </a:ext>
+            </a:extLst>
+          </p:cNvPr>
+          <p:cNvSpPr>
+            <a:spLocks xmlns:a="http://schemas.openxmlformats.org/drawingml/2006/main" noGrp="1"/>
+          </p:cNvSpPr>
+          <p:nvPr/>
+        </p:nvSpPr>
+        <p:spPr>
+          <a:xfrm xmlns:a="http://schemas.openxmlformats.org/drawingml/2006/main">
+            <a:off x="742950" y="4972050"/>
+            <a:ext cx="4953000" cy="266700"/>
+          </a:xfrm>
+          <a:prstGeom xmlns:a="http://schemas.openxmlformats.org/drawingml/2006/main" prst="rect">
+            <a:avLst/>
+          </a:prstGeom>
+          <a:noFill xmlns:a="http://schemas.openxmlformats.org/drawingml/2006/main"/>
+          <a:ln xmlns:a="http://schemas.openxmlformats.org/drawingml/2006/main" w="0">
+            <a:noFill/>
+          </a:ln>
+        </p:spPr>
+        <p:txBody>
+          <a:bodyPr xmlns:a="http://schemas.openxmlformats.org/drawingml/2006/main">
+            <a:noAutofit/>
+          </a:bodyPr>
+          <a:lstStyle xmlns:a="http://schemas.openxmlformats.org/drawingml/2006/main"/>
+          <a:p xmlns:a="http://schemas.openxmlformats.org/drawingml/2006/main">
+            <a:pPr algn="l">
+              <a:defRPr sz="1050" b="1">
+                <a:solidFill>
+                  <a:srgbClr val="17202A"/>
+                </a:solidFill>
+                <a:latin typeface="Arial"/>
+                <a:ea typeface="Arial"/>
+                <a:cs typeface="Arial"/>
+              </a:defRPr>
+            </a:pPr>
+            <a:r>
+              <a:rPr sz="1050" b="1">
+                <a:solidFill>
+                  <a:srgbClr val="17202A"/>
+                </a:solidFill>
+                <a:latin typeface="Arial"/>
+                <a:ea typeface="Arial"/>
+                <a:cs typeface="Arial"/>
+              </a:rPr>
+              <a:t>SUPERVISOR: DR. PHILLIP KISEMBE</a:t>
+            </a:r>
+          </a:p>
+        </p:txBody>
+      </p:sp>
       <p:pic>
         <p:nvPicPr>
-          <p:cNvPr id="9" name=""/>
+          <p:cNvPr id="19" name=""/>
           <p:cNvPicPr>
             <a:picLocks xmlns:a="http://schemas.openxmlformats.org/drawingml/2006/main" noChangeAspect="1"/>
           </p:cNvPicPr>
           <p:nvPr/>
         </p:nvPicPr>
         <p:blipFill>
-          <a:blip xmlns:r="http://schemas.openxmlformats.org/officeDocument/2006/relationships" xmlns:a="http://schemas.openxmlformats.org/drawingml/2006/main" r:embed="R63d8b1a453154cc5"/>
-          <a:srcRect xmlns:a="http://schemas.openxmlformats.org/drawingml/2006/main" l="27689" t="0" r="27689" b="0"/>
+          <a:blip xmlns:r="http://schemas.openxmlformats.org/officeDocument/2006/relationships" xmlns:a="http://schemas.openxmlformats.org/drawingml/2006/main" r:embed="R52e2e4cc544347df"/>
+          <a:srcRect xmlns:a="http://schemas.openxmlformats.org/drawingml/2006/main" l="1214" t="0" r="1214" b="0"/>
           <a:stretch xmlns:a="http://schemas.openxmlformats.org/drawingml/2006/main">
             <a:fillRect l="0" t="0" r="0" b="0"/>
           </a:stretch>
@@ -2270,10 +2578,10 @@
       </p:pic>
       <p:sp>
         <p:nvSpPr>
-          <p:cNvPr id="5" name="">
+          <p:cNvPr id="10" name="">
             <a:extLst xmlns:a="http://schemas.openxmlformats.org/drawingml/2006/main">
               <a:ext uri="{FF2B5EF4-FFF2-40B4-BE49-F238E27FC236}">
-                <a16:creationId xmlns:a16="http://schemas.microsoft.com/office/drawing/2014/main" id="{2C44D3E2-C8AD-49C1-B975-1427D28A3529}"/>
+                <a16:creationId xmlns:a16="http://schemas.microsoft.com/office/drawing/2014/main" id="{678799C2-FA3A-4E64-9BA8-D4A88F2F5238}"/>
               </a:ext>
             </a:extLst>
           </p:cNvPr>
@@ -2328,7 +2636,7 @@
     </p:spTree>
     <p:extLst>
       <p:ext uri="{BB962C8B-B14F-4D97-AF65-F5344CB8AC3E}">
-        <p14:creationId xmlns:p14="http://schemas.microsoft.com/office/powerpoint/2010/main" val="1437114015"/>
+        <p14:creationId xmlns:p14="http://schemas.microsoft.com/office/powerpoint/2010/main" val="612129146"/>
       </p:ext>
     </p:extLst>
   </p:cSld>
@@ -2359,7 +2667,7 @@
           <p:cNvPr id="7" name="">
             <a:extLst xmlns:a="http://schemas.openxmlformats.org/drawingml/2006/main">
               <a:ext uri="{FF2B5EF4-FFF2-40B4-BE49-F238E27FC236}">
-                <a16:creationId xmlns:a16="http://schemas.microsoft.com/office/drawing/2014/main" id="{836B9C39-E7AF-4FD2-950A-6C4943AC2D19}"/>
+                <a16:creationId xmlns:a16="http://schemas.microsoft.com/office/drawing/2014/main" id="{9BB56E49-52EE-4F4A-88A8-7EC0DD786B61}"/>
               </a:ext>
             </a:extLst>
           </p:cNvPr>
@@ -2416,7 +2724,7 @@
           <p:cNvPr id="2" name="">
             <a:extLst xmlns:a="http://schemas.openxmlformats.org/drawingml/2006/main">
               <a:ext uri="{FF2B5EF4-FFF2-40B4-BE49-F238E27FC236}">
-                <a16:creationId xmlns:a16="http://schemas.microsoft.com/office/drawing/2014/main" id="{CEE923A2-3EE2-49DA-8C0C-E6B975FA45BB}"/>
+                <a16:creationId xmlns:a16="http://schemas.microsoft.com/office/drawing/2014/main" id="{2F189C5F-7D83-4CB7-9709-FB432EDC43BC}"/>
               </a:ext>
             </a:extLst>
           </p:cNvPr>
@@ -2473,7 +2781,7 @@
           <p:cNvPr id="3" name="">
             <a:extLst xmlns:a="http://schemas.openxmlformats.org/drawingml/2006/main">
               <a:ext uri="{FF2B5EF4-FFF2-40B4-BE49-F238E27FC236}">
-                <a16:creationId xmlns:a16="http://schemas.microsoft.com/office/drawing/2014/main" id="{BDC997C7-9305-41C4-A35B-6D854B6D836C}"/>
+                <a16:creationId xmlns:a16="http://schemas.microsoft.com/office/drawing/2014/main" id="{AB932491-A73B-41C0-939A-7FB861340CA9}"/>
               </a:ext>
             </a:extLst>
           </p:cNvPr>
@@ -3225,7 +3533,7 @@
           <p:cNvPr id="5" name="">
             <a:extLst xmlns:a="http://schemas.openxmlformats.org/drawingml/2006/main">
               <a:ext uri="{FF2B5EF4-FFF2-40B4-BE49-F238E27FC236}">
-                <a16:creationId xmlns:a16="http://schemas.microsoft.com/office/drawing/2014/main" id="{5158703E-1832-40B1-A212-447998379BC2}"/>
+                <a16:creationId xmlns:a16="http://schemas.microsoft.com/office/drawing/2014/main" id="{CBD53F04-8587-4A01-9B83-707602E020A6}"/>
               </a:ext>
             </a:extLst>
           </p:cNvPr>
@@ -3282,7 +3590,7 @@
           <p:cNvPr id="6" name="">
             <a:extLst xmlns:a="http://schemas.openxmlformats.org/drawingml/2006/main">
               <a:ext uri="{FF2B5EF4-FFF2-40B4-BE49-F238E27FC236}">
-                <a16:creationId xmlns:a16="http://schemas.microsoft.com/office/drawing/2014/main" id="{4EA309DF-47B2-49E7-B0B4-6213DC02B91E}"/>
+                <a16:creationId xmlns:a16="http://schemas.microsoft.com/office/drawing/2014/main" id="{FCF7E3A7-90AC-4847-89D5-3CF8E086D381}"/>
               </a:ext>
             </a:extLst>
           </p:cNvPr>
@@ -3337,7 +3645,7 @@
     </p:spTree>
     <p:extLst>
       <p:ext uri="{BB962C8B-B14F-4D97-AF65-F5344CB8AC3E}">
-        <p14:creationId xmlns:p14="http://schemas.microsoft.com/office/powerpoint/2010/main" val="1787873148"/>
+        <p14:creationId xmlns:p14="http://schemas.microsoft.com/office/powerpoint/2010/main" val="1709805263"/>
       </p:ext>
     </p:extLst>
   </p:cSld>
@@ -3368,7 +3676,7 @@
           <p:cNvPr id="10" name="">
             <a:extLst xmlns:a="http://schemas.openxmlformats.org/drawingml/2006/main">
               <a:ext uri="{FF2B5EF4-FFF2-40B4-BE49-F238E27FC236}">
-                <a16:creationId xmlns:a16="http://schemas.microsoft.com/office/drawing/2014/main" id="{288EE33E-AB9E-40FA-A8BC-533826E07D90}"/>
+                <a16:creationId xmlns:a16="http://schemas.microsoft.com/office/drawing/2014/main" id="{27C714FB-C4A3-4056-9AE7-3DBCA7D21015}"/>
               </a:ext>
             </a:extLst>
           </p:cNvPr>
@@ -3425,7 +3733,7 @@
           <p:cNvPr id="2" name="">
             <a:extLst xmlns:a="http://schemas.openxmlformats.org/drawingml/2006/main">
               <a:ext uri="{FF2B5EF4-FFF2-40B4-BE49-F238E27FC236}">
-                <a16:creationId xmlns:a16="http://schemas.microsoft.com/office/drawing/2014/main" id="{609BC24A-4615-4B53-A62E-B17C7D0FB6BF}"/>
+                <a16:creationId xmlns:a16="http://schemas.microsoft.com/office/drawing/2014/main" id="{25024145-7B85-4A46-B017-6130934EAEE3}"/>
               </a:ext>
             </a:extLst>
           </p:cNvPr>
@@ -3482,7 +3790,7 @@
           <p:cNvPr id="3" name="">
             <a:extLst xmlns:a="http://schemas.openxmlformats.org/drawingml/2006/main">
               <a:ext uri="{FF2B5EF4-FFF2-40B4-BE49-F238E27FC236}">
-                <a16:creationId xmlns:a16="http://schemas.microsoft.com/office/drawing/2014/main" id="{B6E32F43-CD2B-4291-A4AC-578258599D2F}"/>
+                <a16:creationId xmlns:a16="http://schemas.microsoft.com/office/drawing/2014/main" id="{D0F229FC-7D47-4E0D-81C3-24433B89BEC8}"/>
               </a:ext>
             </a:extLst>
           </p:cNvPr>
@@ -3514,7 +3822,7 @@
           <p:cNvPr id="4" name="">
             <a:extLst xmlns:a="http://schemas.openxmlformats.org/drawingml/2006/main">
               <a:ext uri="{FF2B5EF4-FFF2-40B4-BE49-F238E27FC236}">
-                <a16:creationId xmlns:a16="http://schemas.microsoft.com/office/drawing/2014/main" id="{32CC5668-7DFF-4FB9-AE57-0F7A003D82E3}"/>
+                <a16:creationId xmlns:a16="http://schemas.microsoft.com/office/drawing/2014/main" id="{8CC5F957-DA01-4057-8EE8-FED9C7731828}"/>
               </a:ext>
             </a:extLst>
           </p:cNvPr>
@@ -3683,7 +3991,7 @@
           <p:cNvPr id="5" name="">
             <a:extLst xmlns:a="http://schemas.openxmlformats.org/drawingml/2006/main">
               <a:ext uri="{FF2B5EF4-FFF2-40B4-BE49-F238E27FC236}">
-                <a16:creationId xmlns:a16="http://schemas.microsoft.com/office/drawing/2014/main" id="{271EFF1B-256A-415C-B956-64322B26CEC0}"/>
+                <a16:creationId xmlns:a16="http://schemas.microsoft.com/office/drawing/2014/main" id="{5A615588-3C14-436B-8B55-8F1A7740D73F}"/>
               </a:ext>
             </a:extLst>
           </p:cNvPr>
@@ -3740,7 +4048,7 @@
           <p:cNvPr id="6" name="">
             <a:extLst xmlns:a="http://schemas.openxmlformats.org/drawingml/2006/main">
               <a:ext uri="{FF2B5EF4-FFF2-40B4-BE49-F238E27FC236}">
-                <a16:creationId xmlns:a16="http://schemas.microsoft.com/office/drawing/2014/main" id="{1C285DB8-3B8A-4769-8300-36D5829BBEA5}"/>
+                <a16:creationId xmlns:a16="http://schemas.microsoft.com/office/drawing/2014/main" id="{2390BF8C-F4FA-43F1-8D04-F22CE0084A02}"/>
               </a:ext>
             </a:extLst>
           </p:cNvPr>
@@ -3797,7 +4105,7 @@
           <p:cNvPr id="7" name="">
             <a:extLst xmlns:a="http://schemas.openxmlformats.org/drawingml/2006/main">
               <a:ext uri="{FF2B5EF4-FFF2-40B4-BE49-F238E27FC236}">
-                <a16:creationId xmlns:a16="http://schemas.microsoft.com/office/drawing/2014/main" id="{5913125A-F3CE-40C8-8490-F83A3C1ABCD1}"/>
+                <a16:creationId xmlns:a16="http://schemas.microsoft.com/office/drawing/2014/main" id="{8EAD2D32-1DB8-4032-9D15-7CEA477DE3AC}"/>
               </a:ext>
             </a:extLst>
           </p:cNvPr>
@@ -3854,7 +4162,7 @@
           <p:cNvPr id="8" name="">
             <a:extLst xmlns:a="http://schemas.openxmlformats.org/drawingml/2006/main">
               <a:ext uri="{FF2B5EF4-FFF2-40B4-BE49-F238E27FC236}">
-                <a16:creationId xmlns:a16="http://schemas.microsoft.com/office/drawing/2014/main" id="{442935A1-D991-4AE5-AD04-0ADFF03642AB}"/>
+                <a16:creationId xmlns:a16="http://schemas.microsoft.com/office/drawing/2014/main" id="{E341B4BC-6C08-4C7A-89C8-A58E12D9101A}"/>
               </a:ext>
             </a:extLst>
           </p:cNvPr>
@@ -3911,7 +4219,7 @@
           <p:cNvPr id="9" name="">
             <a:extLst xmlns:a="http://schemas.openxmlformats.org/drawingml/2006/main">
               <a:ext uri="{FF2B5EF4-FFF2-40B4-BE49-F238E27FC236}">
-                <a16:creationId xmlns:a16="http://schemas.microsoft.com/office/drawing/2014/main" id="{990D3A64-F2FF-4087-B6A1-1C97EC75E3EA}"/>
+                <a16:creationId xmlns:a16="http://schemas.microsoft.com/office/drawing/2014/main" id="{BDCB8A60-D38C-4698-8425-A8CDC7341823}"/>
               </a:ext>
             </a:extLst>
           </p:cNvPr>
@@ -3966,7 +4274,7 @@
     </p:spTree>
     <p:extLst>
       <p:ext uri="{BB962C8B-B14F-4D97-AF65-F5344CB8AC3E}">
-        <p14:creationId xmlns:p14="http://schemas.microsoft.com/office/powerpoint/2010/main" val="377829680"/>
+        <p14:creationId xmlns:p14="http://schemas.microsoft.com/office/powerpoint/2010/main" val="903009056"/>
       </p:ext>
     </p:extLst>
   </p:cSld>
@@ -3997,7 +4305,7 @@
           <p:cNvPr id="12" name="">
             <a:extLst xmlns:a="http://schemas.openxmlformats.org/drawingml/2006/main">
               <a:ext uri="{FF2B5EF4-FFF2-40B4-BE49-F238E27FC236}">
-                <a16:creationId xmlns:a16="http://schemas.microsoft.com/office/drawing/2014/main" id="{0130DBA0-8F36-48AF-890D-C570890C5450}"/>
+                <a16:creationId xmlns:a16="http://schemas.microsoft.com/office/drawing/2014/main" id="{F97C9A06-A90F-4DE0-AA82-CEF1B29E81FF}"/>
               </a:ext>
             </a:extLst>
           </p:cNvPr>
@@ -4054,7 +4362,7 @@
           <p:cNvPr id="2" name="">
             <a:extLst xmlns:a="http://schemas.openxmlformats.org/drawingml/2006/main">
               <a:ext uri="{FF2B5EF4-FFF2-40B4-BE49-F238E27FC236}">
-                <a16:creationId xmlns:a16="http://schemas.microsoft.com/office/drawing/2014/main" id="{F52CC0E5-2549-4946-9B8D-379244431169}"/>
+                <a16:creationId xmlns:a16="http://schemas.microsoft.com/office/drawing/2014/main" id="{11F04E70-8A31-4384-BFA3-9EA9463B7AED}"/>
               </a:ext>
             </a:extLst>
           </p:cNvPr>
@@ -4111,7 +4419,7 @@
           <p:cNvPr id="3" name="">
             <a:extLst xmlns:a="http://schemas.openxmlformats.org/drawingml/2006/main">
               <a:ext uri="{FF2B5EF4-FFF2-40B4-BE49-F238E27FC236}">
-                <a16:creationId xmlns:a16="http://schemas.microsoft.com/office/drawing/2014/main" id="{17D77E2F-12DD-41E2-8BCA-6659113290B8}"/>
+                <a16:creationId xmlns:a16="http://schemas.microsoft.com/office/drawing/2014/main" id="{611647AA-E698-4097-9A04-ADEA98996F53}"/>
               </a:ext>
             </a:extLst>
           </p:cNvPr>
@@ -4143,7 +4451,7 @@
           <p:cNvPr id="4" name="">
             <a:extLst xmlns:a="http://schemas.openxmlformats.org/drawingml/2006/main">
               <a:ext uri="{FF2B5EF4-FFF2-40B4-BE49-F238E27FC236}">
-                <a16:creationId xmlns:a16="http://schemas.microsoft.com/office/drawing/2014/main" id="{15AD0BF8-0DC2-4592-BBEE-FA3E02A30972}"/>
+                <a16:creationId xmlns:a16="http://schemas.microsoft.com/office/drawing/2014/main" id="{3F064490-17DE-4679-86A4-F557DD1CCBFF}"/>
               </a:ext>
             </a:extLst>
           </p:cNvPr>
@@ -4285,7 +4593,7 @@
           <p:cNvPr id="5" name="">
             <a:extLst xmlns:a="http://schemas.openxmlformats.org/drawingml/2006/main">
               <a:ext uri="{FF2B5EF4-FFF2-40B4-BE49-F238E27FC236}">
-                <a16:creationId xmlns:a16="http://schemas.microsoft.com/office/drawing/2014/main" id="{66277B09-D4FE-4043-AA6B-49984577964D}"/>
+                <a16:creationId xmlns:a16="http://schemas.microsoft.com/office/drawing/2014/main" id="{55260B71-39A4-4CCD-8BD2-F219CF137707}"/>
               </a:ext>
             </a:extLst>
           </p:cNvPr>
@@ -4342,7 +4650,7 @@
           <p:cNvPr id="6" name="">
             <a:extLst xmlns:a="http://schemas.openxmlformats.org/drawingml/2006/main">
               <a:ext uri="{FF2B5EF4-FFF2-40B4-BE49-F238E27FC236}">
-                <a16:creationId xmlns:a16="http://schemas.microsoft.com/office/drawing/2014/main" id="{95C5E4D1-B891-4D6F-850E-C07ABEC10207}"/>
+                <a16:creationId xmlns:a16="http://schemas.microsoft.com/office/drawing/2014/main" id="{7782B456-4AE6-4E3E-AC65-D2B0CE7A3E43}"/>
               </a:ext>
             </a:extLst>
           </p:cNvPr>
@@ -4399,7 +4707,7 @@
           <p:cNvPr id="7" name="">
             <a:extLst xmlns:a="http://schemas.openxmlformats.org/drawingml/2006/main">
               <a:ext uri="{FF2B5EF4-FFF2-40B4-BE49-F238E27FC236}">
-                <a16:creationId xmlns:a16="http://schemas.microsoft.com/office/drawing/2014/main" id="{D20179BC-6F6B-4B35-B0FB-1C099A94CAFC}"/>
+                <a16:creationId xmlns:a16="http://schemas.microsoft.com/office/drawing/2014/main" id="{CBD7E109-EDC0-4BF8-940F-4E252DD46C34}"/>
               </a:ext>
             </a:extLst>
           </p:cNvPr>
@@ -4456,7 +4764,7 @@
           <p:cNvPr id="8" name="">
             <a:extLst xmlns:a="http://schemas.openxmlformats.org/drawingml/2006/main">
               <a:ext uri="{FF2B5EF4-FFF2-40B4-BE49-F238E27FC236}">
-                <a16:creationId xmlns:a16="http://schemas.microsoft.com/office/drawing/2014/main" id="{3015345D-A9F2-4B71-9F8D-750ACCE4D19F}"/>
+                <a16:creationId xmlns:a16="http://schemas.microsoft.com/office/drawing/2014/main" id="{2426A295-7D3C-4017-BF02-46F2FFE9B369}"/>
               </a:ext>
             </a:extLst>
           </p:cNvPr>
@@ -4513,7 +4821,7 @@
           <p:cNvPr id="9" name="">
             <a:extLst xmlns:a="http://schemas.openxmlformats.org/drawingml/2006/main">
               <a:ext uri="{FF2B5EF4-FFF2-40B4-BE49-F238E27FC236}">
-                <a16:creationId xmlns:a16="http://schemas.microsoft.com/office/drawing/2014/main" id="{67E0AC07-EC97-4FC4-87D9-2C5B240F9165}"/>
+                <a16:creationId xmlns:a16="http://schemas.microsoft.com/office/drawing/2014/main" id="{60434E75-6AD4-4F95-9E68-D5969DD9DBB5}"/>
               </a:ext>
             </a:extLst>
           </p:cNvPr>
@@ -4570,7 +4878,7 @@
           <p:cNvPr id="10" name="">
             <a:extLst xmlns:a="http://schemas.openxmlformats.org/drawingml/2006/main">
               <a:ext uri="{FF2B5EF4-FFF2-40B4-BE49-F238E27FC236}">
-                <a16:creationId xmlns:a16="http://schemas.microsoft.com/office/drawing/2014/main" id="{C5C2D457-7CD3-4196-AD1B-9E01833399C6}"/>
+                <a16:creationId xmlns:a16="http://schemas.microsoft.com/office/drawing/2014/main" id="{7E0576EF-626C-4186-A50D-8CD6C1ED7289}"/>
               </a:ext>
             </a:extLst>
           </p:cNvPr>
@@ -4627,7 +4935,7 @@
           <p:cNvPr id="11" name="">
             <a:extLst xmlns:a="http://schemas.openxmlformats.org/drawingml/2006/main">
               <a:ext uri="{FF2B5EF4-FFF2-40B4-BE49-F238E27FC236}">
-                <a16:creationId xmlns:a16="http://schemas.microsoft.com/office/drawing/2014/main" id="{005FD6E3-105E-41C8-AF57-99A9C049AB45}"/>
+                <a16:creationId xmlns:a16="http://schemas.microsoft.com/office/drawing/2014/main" id="{34114347-BEBC-469F-9B0C-37F4CFE0C4F2}"/>
               </a:ext>
             </a:extLst>
           </p:cNvPr>
@@ -4682,7 +4990,7 @@
     </p:spTree>
     <p:extLst>
       <p:ext uri="{BB962C8B-B14F-4D97-AF65-F5344CB8AC3E}">
-        <p14:creationId xmlns:p14="http://schemas.microsoft.com/office/powerpoint/2010/main" val="686673661"/>
+        <p14:creationId xmlns:p14="http://schemas.microsoft.com/office/powerpoint/2010/main" val="1664283037"/>
       </p:ext>
     </p:extLst>
   </p:cSld>
@@ -4713,7 +5021,7 @@
           <p:cNvPr id="12" name="">
             <a:extLst xmlns:a="http://schemas.openxmlformats.org/drawingml/2006/main">
               <a:ext uri="{FF2B5EF4-FFF2-40B4-BE49-F238E27FC236}">
-                <a16:creationId xmlns:a16="http://schemas.microsoft.com/office/drawing/2014/main" id="{A68006EB-786A-453C-AC09-7295AEE4848B}"/>
+                <a16:creationId xmlns:a16="http://schemas.microsoft.com/office/drawing/2014/main" id="{FC6EA89F-8413-449A-806F-F0BCDBEC0710}"/>
               </a:ext>
             </a:extLst>
           </p:cNvPr>
@@ -4770,7 +5078,7 @@
           <p:cNvPr id="2" name="">
             <a:extLst xmlns:a="http://schemas.openxmlformats.org/drawingml/2006/main">
               <a:ext uri="{FF2B5EF4-FFF2-40B4-BE49-F238E27FC236}">
-                <a16:creationId xmlns:a16="http://schemas.microsoft.com/office/drawing/2014/main" id="{F1075B5F-5539-48F7-BE34-57A69E41ECF3}"/>
+                <a16:creationId xmlns:a16="http://schemas.microsoft.com/office/drawing/2014/main" id="{C965D8B1-2C6B-419F-AA10-A369B7884168}"/>
               </a:ext>
             </a:extLst>
           </p:cNvPr>
@@ -4827,7 +5135,7 @@
           <p:cNvPr id="3" name="">
             <a:extLst xmlns:a="http://schemas.openxmlformats.org/drawingml/2006/main">
               <a:ext uri="{FF2B5EF4-FFF2-40B4-BE49-F238E27FC236}">
-                <a16:creationId xmlns:a16="http://schemas.microsoft.com/office/drawing/2014/main" id="{8A5764C6-71FA-40EF-9E8F-4722FCDBF24D}"/>
+                <a16:creationId xmlns:a16="http://schemas.microsoft.com/office/drawing/2014/main" id="{F2851D37-1A44-4F34-8FA4-607EEC521AB7}"/>
               </a:ext>
             </a:extLst>
           </p:cNvPr>
@@ -4859,7 +5167,7 @@
           <p:cNvPr id="4" name="">
             <a:extLst xmlns:a="http://schemas.openxmlformats.org/drawingml/2006/main">
               <a:ext uri="{FF2B5EF4-FFF2-40B4-BE49-F238E27FC236}">
-                <a16:creationId xmlns:a16="http://schemas.microsoft.com/office/drawing/2014/main" id="{3E17E287-5FF9-4ED4-A228-7CDA0AFE0082}"/>
+                <a16:creationId xmlns:a16="http://schemas.microsoft.com/office/drawing/2014/main" id="{61781FD5-3C5F-4EA2-8092-03A1A90402F4}"/>
               </a:ext>
             </a:extLst>
           </p:cNvPr>
@@ -5028,7 +5336,7 @@
           <p:cNvPr id="5" name="">
             <a:extLst xmlns:a="http://schemas.openxmlformats.org/drawingml/2006/main">
               <a:ext uri="{FF2B5EF4-FFF2-40B4-BE49-F238E27FC236}">
-                <a16:creationId xmlns:a16="http://schemas.microsoft.com/office/drawing/2014/main" id="{49AC3B5C-B2B0-46F9-BEA1-6D8C4B217FCB}"/>
+                <a16:creationId xmlns:a16="http://schemas.microsoft.com/office/drawing/2014/main" id="{F63972B0-5C41-4BC5-9808-737B7BD7F83E}"/>
               </a:ext>
             </a:extLst>
           </p:cNvPr>
@@ -5085,7 +5393,7 @@
           <p:cNvPr id="6" name="">
             <a:extLst xmlns:a="http://schemas.openxmlformats.org/drawingml/2006/main">
               <a:ext uri="{FF2B5EF4-FFF2-40B4-BE49-F238E27FC236}">
-                <a16:creationId xmlns:a16="http://schemas.microsoft.com/office/drawing/2014/main" id="{55C4267D-EDDE-4B46-9177-63B29E998688}"/>
+                <a16:creationId xmlns:a16="http://schemas.microsoft.com/office/drawing/2014/main" id="{24E5EEF6-2FE7-4F09-8819-148A218D93D9}"/>
               </a:ext>
             </a:extLst>
           </p:cNvPr>
@@ -5142,7 +5450,7 @@
           <p:cNvPr id="7" name="">
             <a:extLst xmlns:a="http://schemas.openxmlformats.org/drawingml/2006/main">
               <a:ext uri="{FF2B5EF4-FFF2-40B4-BE49-F238E27FC236}">
-                <a16:creationId xmlns:a16="http://schemas.microsoft.com/office/drawing/2014/main" id="{59053E82-5107-4167-B7C4-1CD065A95AC2}"/>
+                <a16:creationId xmlns:a16="http://schemas.microsoft.com/office/drawing/2014/main" id="{DF478462-88B3-4DB0-B123-53E59853D9A2}"/>
               </a:ext>
             </a:extLst>
           </p:cNvPr>
@@ -5199,7 +5507,7 @@
           <p:cNvPr id="8" name="">
             <a:extLst xmlns:a="http://schemas.openxmlformats.org/drawingml/2006/main">
               <a:ext uri="{FF2B5EF4-FFF2-40B4-BE49-F238E27FC236}">
-                <a16:creationId xmlns:a16="http://schemas.microsoft.com/office/drawing/2014/main" id="{A5075AEE-E7FD-4D6D-8C06-3D2F8387A978}"/>
+                <a16:creationId xmlns:a16="http://schemas.microsoft.com/office/drawing/2014/main" id="{993E41A9-F896-421E-AEA9-CABF8139D6C4}"/>
               </a:ext>
             </a:extLst>
           </p:cNvPr>
@@ -5256,7 +5564,7 @@
           <p:cNvPr id="9" name="">
             <a:extLst xmlns:a="http://schemas.openxmlformats.org/drawingml/2006/main">
               <a:ext uri="{FF2B5EF4-FFF2-40B4-BE49-F238E27FC236}">
-                <a16:creationId xmlns:a16="http://schemas.microsoft.com/office/drawing/2014/main" id="{BF2AAF04-BAD4-46CC-A1BE-1799A5023E00}"/>
+                <a16:creationId xmlns:a16="http://schemas.microsoft.com/office/drawing/2014/main" id="{593A8C29-DB8E-4549-9DEE-1274DCFB8A3C}"/>
               </a:ext>
             </a:extLst>
           </p:cNvPr>
@@ -5313,7 +5621,7 @@
           <p:cNvPr id="10" name="">
             <a:extLst xmlns:a="http://schemas.openxmlformats.org/drawingml/2006/main">
               <a:ext uri="{FF2B5EF4-FFF2-40B4-BE49-F238E27FC236}">
-                <a16:creationId xmlns:a16="http://schemas.microsoft.com/office/drawing/2014/main" id="{45544367-C71D-45DD-8332-089F593AD940}"/>
+                <a16:creationId xmlns:a16="http://schemas.microsoft.com/office/drawing/2014/main" id="{779F4A77-E3C0-4774-B2B1-D228DD8A5162}"/>
               </a:ext>
             </a:extLst>
           </p:cNvPr>
@@ -5370,7 +5678,7 @@
           <p:cNvPr id="11" name="">
             <a:extLst xmlns:a="http://schemas.openxmlformats.org/drawingml/2006/main">
               <a:ext uri="{FF2B5EF4-FFF2-40B4-BE49-F238E27FC236}">
-                <a16:creationId xmlns:a16="http://schemas.microsoft.com/office/drawing/2014/main" id="{4EF92DA9-F421-4D1C-BF87-5E4B7BBFADF1}"/>
+                <a16:creationId xmlns:a16="http://schemas.microsoft.com/office/drawing/2014/main" id="{34F23A64-B4C3-48D6-B24D-6ACA590D6D09}"/>
               </a:ext>
             </a:extLst>
           </p:cNvPr>
@@ -5425,7 +5733,7 @@
     </p:spTree>
     <p:extLst>
       <p:ext uri="{BB962C8B-B14F-4D97-AF65-F5344CB8AC3E}">
-        <p14:creationId xmlns:p14="http://schemas.microsoft.com/office/powerpoint/2010/main" val="621631664"/>
+        <p14:creationId xmlns:p14="http://schemas.microsoft.com/office/powerpoint/2010/main" val="1069235697"/>
       </p:ext>
     </p:extLst>
   </p:cSld>
@@ -5456,7 +5764,7 @@
           <p:cNvPr id="6" name="">
             <a:extLst xmlns:a="http://schemas.openxmlformats.org/drawingml/2006/main">
               <a:ext uri="{FF2B5EF4-FFF2-40B4-BE49-F238E27FC236}">
-                <a16:creationId xmlns:a16="http://schemas.microsoft.com/office/drawing/2014/main" id="{9485D789-D320-4584-AD51-ECD0BC8097A5}"/>
+                <a16:creationId xmlns:a16="http://schemas.microsoft.com/office/drawing/2014/main" id="{5427C0B8-C06D-451D-8BE1-6B87746FF14F}"/>
               </a:ext>
             </a:extLst>
           </p:cNvPr>
@@ -5513,7 +5821,7 @@
           <p:cNvPr id="2" name="">
             <a:extLst xmlns:a="http://schemas.openxmlformats.org/drawingml/2006/main">
               <a:ext uri="{FF2B5EF4-FFF2-40B4-BE49-F238E27FC236}">
-                <a16:creationId xmlns:a16="http://schemas.microsoft.com/office/drawing/2014/main" id="{9B6898CF-BE73-4D17-92CB-A54B06235F66}"/>
+                <a16:creationId xmlns:a16="http://schemas.microsoft.com/office/drawing/2014/main" id="{DE47410F-00FF-4E3F-A1EE-832096390E54}"/>
               </a:ext>
             </a:extLst>
           </p:cNvPr>
@@ -5570,7 +5878,7 @@
           <p:cNvPr id="3" name="">
             <a:extLst xmlns:a="http://schemas.openxmlformats.org/drawingml/2006/main">
               <a:ext uri="{FF2B5EF4-FFF2-40B4-BE49-F238E27FC236}">
-                <a16:creationId xmlns:a16="http://schemas.microsoft.com/office/drawing/2014/main" id="{6CD2EF07-544F-4B01-8E6C-30E5B7896A58}"/>
+                <a16:creationId xmlns:a16="http://schemas.microsoft.com/office/drawing/2014/main" id="{E60C1686-5709-4AF4-A1AD-DEF3BB2F4E89}"/>
               </a:ext>
             </a:extLst>
           </p:cNvPr>
@@ -5954,7 +6262,7 @@
           <p:cNvPr id="5" name="">
             <a:extLst xmlns:a="http://schemas.openxmlformats.org/drawingml/2006/main">
               <a:ext uri="{FF2B5EF4-FFF2-40B4-BE49-F238E27FC236}">
-                <a16:creationId xmlns:a16="http://schemas.microsoft.com/office/drawing/2014/main" id="{F336D717-ECDF-49C6-A9FF-559AA306091A}"/>
+                <a16:creationId xmlns:a16="http://schemas.microsoft.com/office/drawing/2014/main" id="{E6105C1D-438E-49F0-9D34-42142A189B5E}"/>
               </a:ext>
             </a:extLst>
           </p:cNvPr>
@@ -6009,7 +6317,7 @@
     </p:spTree>
     <p:extLst>
       <p:ext uri="{BB962C8B-B14F-4D97-AF65-F5344CB8AC3E}">
-        <p14:creationId xmlns:p14="http://schemas.microsoft.com/office/powerpoint/2010/main" val="1780798670"/>
+        <p14:creationId xmlns:p14="http://schemas.microsoft.com/office/powerpoint/2010/main" val="1291448608"/>
       </p:ext>
     </p:extLst>
   </p:cSld>
@@ -6040,7 +6348,7 @@
           <p:cNvPr id="7" name="">
             <a:extLst xmlns:a="http://schemas.openxmlformats.org/drawingml/2006/main">
               <a:ext uri="{FF2B5EF4-FFF2-40B4-BE49-F238E27FC236}">
-                <a16:creationId xmlns:a16="http://schemas.microsoft.com/office/drawing/2014/main" id="{F4FB348C-BD09-42C0-82EA-375935BE7BFE}"/>
+                <a16:creationId xmlns:a16="http://schemas.microsoft.com/office/drawing/2014/main" id="{EC36C112-125A-4ED6-80EC-94637B520AD5}"/>
               </a:ext>
             </a:extLst>
           </p:cNvPr>
@@ -6097,7 +6405,7 @@
           <p:cNvPr id="2" name="">
             <a:extLst xmlns:a="http://schemas.openxmlformats.org/drawingml/2006/main">
               <a:ext uri="{FF2B5EF4-FFF2-40B4-BE49-F238E27FC236}">
-                <a16:creationId xmlns:a16="http://schemas.microsoft.com/office/drawing/2014/main" id="{4053F0A8-1FA5-42EA-A946-EB2C2057E3BB}"/>
+                <a16:creationId xmlns:a16="http://schemas.microsoft.com/office/drawing/2014/main" id="{27814D18-0545-489A-A243-AB8434B0DAE1}"/>
               </a:ext>
             </a:extLst>
           </p:cNvPr>
@@ -6154,7 +6462,7 @@
           <p:cNvPr id="3" name="">
             <a:extLst xmlns:a="http://schemas.openxmlformats.org/drawingml/2006/main">
               <a:ext uri="{FF2B5EF4-FFF2-40B4-BE49-F238E27FC236}">
-                <a16:creationId xmlns:a16="http://schemas.microsoft.com/office/drawing/2014/main" id="{EF02ED05-4859-41B9-89F2-D8D6D3B99A53}"/>
+                <a16:creationId xmlns:a16="http://schemas.microsoft.com/office/drawing/2014/main" id="{C860BCC7-10C0-4DAF-8A94-BB0093861962}"/>
               </a:ext>
             </a:extLst>
           </p:cNvPr>
@@ -6561,7 +6869,7 @@
           <p:cNvPr id="5" name="">
             <a:extLst xmlns:a="http://schemas.openxmlformats.org/drawingml/2006/main">
               <a:ext uri="{FF2B5EF4-FFF2-40B4-BE49-F238E27FC236}">
-                <a16:creationId xmlns:a16="http://schemas.microsoft.com/office/drawing/2014/main" id="{3FA47E93-F263-491C-9570-100FF58E5DD4}"/>
+                <a16:creationId xmlns:a16="http://schemas.microsoft.com/office/drawing/2014/main" id="{7B997BD6-0B3F-47C6-B899-BC26B2B9467D}"/>
               </a:ext>
             </a:extLst>
           </p:cNvPr>
@@ -6618,7 +6926,7 @@
           <p:cNvPr id="6" name="">
             <a:extLst xmlns:a="http://schemas.openxmlformats.org/drawingml/2006/main">
               <a:ext uri="{FF2B5EF4-FFF2-40B4-BE49-F238E27FC236}">
-                <a16:creationId xmlns:a16="http://schemas.microsoft.com/office/drawing/2014/main" id="{1660525E-E1C0-40FD-9479-3D00BFE1422B}"/>
+                <a16:creationId xmlns:a16="http://schemas.microsoft.com/office/drawing/2014/main" id="{345DA0E6-9D07-4431-A89C-D97749252028}"/>
               </a:ext>
             </a:extLst>
           </p:cNvPr>
@@ -6673,7 +6981,7 @@
     </p:spTree>
     <p:extLst>
       <p:ext uri="{BB962C8B-B14F-4D97-AF65-F5344CB8AC3E}">
-        <p14:creationId xmlns:p14="http://schemas.microsoft.com/office/powerpoint/2010/main" val="1393770295"/>
+        <p14:creationId xmlns:p14="http://schemas.microsoft.com/office/powerpoint/2010/main" val="1857656379"/>
       </p:ext>
     </p:extLst>
   </p:cSld>
@@ -6704,7 +7012,7 @@
           <p:cNvPr id="10" name="">
             <a:extLst xmlns:a="http://schemas.openxmlformats.org/drawingml/2006/main">
               <a:ext uri="{FF2B5EF4-FFF2-40B4-BE49-F238E27FC236}">
-                <a16:creationId xmlns:a16="http://schemas.microsoft.com/office/drawing/2014/main" id="{910D6BDE-3D37-4791-A19B-5A5BB1444E4E}"/>
+                <a16:creationId xmlns:a16="http://schemas.microsoft.com/office/drawing/2014/main" id="{D85AAB2D-9EA5-435D-BAD1-214B71399ABF}"/>
               </a:ext>
             </a:extLst>
           </p:cNvPr>
@@ -6761,7 +7069,7 @@
           <p:cNvPr id="2" name="">
             <a:extLst xmlns:a="http://schemas.openxmlformats.org/drawingml/2006/main">
               <a:ext uri="{FF2B5EF4-FFF2-40B4-BE49-F238E27FC236}">
-                <a16:creationId xmlns:a16="http://schemas.microsoft.com/office/drawing/2014/main" id="{8E56D976-71E2-495E-8C45-83E49C3818E5}"/>
+                <a16:creationId xmlns:a16="http://schemas.microsoft.com/office/drawing/2014/main" id="{7FFC1A62-AB63-4A9C-9BB6-2F53D23D1477}"/>
               </a:ext>
             </a:extLst>
           </p:cNvPr>
@@ -6818,7 +7126,7 @@
           <p:cNvPr id="3" name="">
             <a:extLst xmlns:a="http://schemas.openxmlformats.org/drawingml/2006/main">
               <a:ext uri="{FF2B5EF4-FFF2-40B4-BE49-F238E27FC236}">
-                <a16:creationId xmlns:a16="http://schemas.microsoft.com/office/drawing/2014/main" id="{990749FA-88EB-4C5F-B7E2-9C12222D1140}"/>
+                <a16:creationId xmlns:a16="http://schemas.microsoft.com/office/drawing/2014/main" id="{0120DE3C-322E-4CB3-9D36-7914A876195B}"/>
               </a:ext>
             </a:extLst>
           </p:cNvPr>
@@ -6850,7 +7158,7 @@
           <p:cNvPr id="4" name="">
             <a:extLst xmlns:a="http://schemas.openxmlformats.org/drawingml/2006/main">
               <a:ext uri="{FF2B5EF4-FFF2-40B4-BE49-F238E27FC236}">
-                <a16:creationId xmlns:a16="http://schemas.microsoft.com/office/drawing/2014/main" id="{6F2A94AB-31EB-40BA-BAB7-7B4F16D60832}"/>
+                <a16:creationId xmlns:a16="http://schemas.microsoft.com/office/drawing/2014/main" id="{42120BA4-6C7D-4401-B268-2F0124EE6588}"/>
               </a:ext>
             </a:extLst>
           </p:cNvPr>
@@ -6907,7 +7215,7 @@
           <p:cNvPr id="5" name="">
             <a:extLst xmlns:a="http://schemas.openxmlformats.org/drawingml/2006/main">
               <a:ext uri="{FF2B5EF4-FFF2-40B4-BE49-F238E27FC236}">
-                <a16:creationId xmlns:a16="http://schemas.microsoft.com/office/drawing/2014/main" id="{03F80206-85D1-4ECC-A6F6-487764C6889A}"/>
+                <a16:creationId xmlns:a16="http://schemas.microsoft.com/office/drawing/2014/main" id="{0F972370-92D2-4FF3-942D-DBA0FF13567D}"/>
               </a:ext>
             </a:extLst>
           </p:cNvPr>
@@ -6964,7 +7272,7 @@
           <p:cNvPr id="6" name="">
             <a:extLst xmlns:a="http://schemas.openxmlformats.org/drawingml/2006/main">
               <a:ext uri="{FF2B5EF4-FFF2-40B4-BE49-F238E27FC236}">
-                <a16:creationId xmlns:a16="http://schemas.microsoft.com/office/drawing/2014/main" id="{47490C62-E7FC-43BC-9895-AFEE9DD29ED6}"/>
+                <a16:creationId xmlns:a16="http://schemas.microsoft.com/office/drawing/2014/main" id="{E0676979-CC33-4E33-A6BD-12749E65D97C}"/>
               </a:ext>
             </a:extLst>
           </p:cNvPr>
@@ -7106,7 +7414,7 @@
           <p:cNvPr id="7" name="">
             <a:extLst xmlns:a="http://schemas.openxmlformats.org/drawingml/2006/main">
               <a:ext uri="{FF2B5EF4-FFF2-40B4-BE49-F238E27FC236}">
-                <a16:creationId xmlns:a16="http://schemas.microsoft.com/office/drawing/2014/main" id="{D1509A22-D6D9-47A2-A1B6-AD8CF592EDD5}"/>
+                <a16:creationId xmlns:a16="http://schemas.microsoft.com/office/drawing/2014/main" id="{659EEFE9-08DE-47B1-98E5-F950BF1DA190}"/>
               </a:ext>
             </a:extLst>
           </p:cNvPr>
@@ -7163,7 +7471,7 @@
           <p:cNvPr id="8" name="">
             <a:extLst xmlns:a="http://schemas.openxmlformats.org/drawingml/2006/main">
               <a:ext uri="{FF2B5EF4-FFF2-40B4-BE49-F238E27FC236}">
-                <a16:creationId xmlns:a16="http://schemas.microsoft.com/office/drawing/2014/main" id="{CB52D869-9A23-4116-A701-D8AA3DC18B95}"/>
+                <a16:creationId xmlns:a16="http://schemas.microsoft.com/office/drawing/2014/main" id="{8499A74A-DCDD-4DB3-BE91-DB8D2B91A30C}"/>
               </a:ext>
             </a:extLst>
           </p:cNvPr>
@@ -7220,7 +7528,7 @@
           <p:cNvPr id="9" name="">
             <a:extLst xmlns:a="http://schemas.openxmlformats.org/drawingml/2006/main">
               <a:ext uri="{FF2B5EF4-FFF2-40B4-BE49-F238E27FC236}">
-                <a16:creationId xmlns:a16="http://schemas.microsoft.com/office/drawing/2014/main" id="{7A4C834F-8927-4826-9316-457A55F586A0}"/>
+                <a16:creationId xmlns:a16="http://schemas.microsoft.com/office/drawing/2014/main" id="{F10213F1-CB6E-4CEB-9850-AF57DDEFA036}"/>
               </a:ext>
             </a:extLst>
           </p:cNvPr>
@@ -7275,7 +7583,7 @@
     </p:spTree>
     <p:extLst>
       <p:ext uri="{BB962C8B-B14F-4D97-AF65-F5344CB8AC3E}">
-        <p14:creationId xmlns:p14="http://schemas.microsoft.com/office/powerpoint/2010/main" val="906583582"/>
+        <p14:creationId xmlns:p14="http://schemas.microsoft.com/office/powerpoint/2010/main" val="1874689179"/>
       </p:ext>
     </p:extLst>
   </p:cSld>
@@ -7306,7 +7614,7 @@
           <p:cNvPr id="8" name="">
             <a:extLst xmlns:a="http://schemas.openxmlformats.org/drawingml/2006/main">
               <a:ext uri="{FF2B5EF4-FFF2-40B4-BE49-F238E27FC236}">
-                <a16:creationId xmlns:a16="http://schemas.microsoft.com/office/drawing/2014/main" id="{BDE58F96-689E-424A-AC5C-AAE510FFA8DB}"/>
+                <a16:creationId xmlns:a16="http://schemas.microsoft.com/office/drawing/2014/main" id="{CE489544-4B42-4D39-A7C5-186044F893D4}"/>
               </a:ext>
             </a:extLst>
           </p:cNvPr>
@@ -7363,7 +7671,7 @@
           <p:cNvPr id="2" name="">
             <a:extLst xmlns:a="http://schemas.openxmlformats.org/drawingml/2006/main">
               <a:ext uri="{FF2B5EF4-FFF2-40B4-BE49-F238E27FC236}">
-                <a16:creationId xmlns:a16="http://schemas.microsoft.com/office/drawing/2014/main" id="{1FAA2C49-E303-4A7D-8525-FC31EC581A0B}"/>
+                <a16:creationId xmlns:a16="http://schemas.microsoft.com/office/drawing/2014/main" id="{908DEA00-F656-408F-A797-ADC21924C5B9}"/>
               </a:ext>
             </a:extLst>
           </p:cNvPr>
@@ -7420,7 +7728,7 @@
           <p:cNvPr id="3" name="">
             <a:extLst xmlns:a="http://schemas.openxmlformats.org/drawingml/2006/main">
               <a:ext uri="{FF2B5EF4-FFF2-40B4-BE49-F238E27FC236}">
-                <a16:creationId xmlns:a16="http://schemas.microsoft.com/office/drawing/2014/main" id="{FAABEEA6-1E6C-494A-84E2-CD035941A52F}"/>
+                <a16:creationId xmlns:a16="http://schemas.microsoft.com/office/drawing/2014/main" id="{CA503899-1ABA-4CD2-9494-4AAB41380DF3}"/>
               </a:ext>
             </a:extLst>
           </p:cNvPr>
@@ -7452,7 +7760,7 @@
           <p:cNvPr id="4" name="">
             <a:extLst xmlns:a="http://schemas.openxmlformats.org/drawingml/2006/main">
               <a:ext uri="{FF2B5EF4-FFF2-40B4-BE49-F238E27FC236}">
-                <a16:creationId xmlns:a16="http://schemas.microsoft.com/office/drawing/2014/main" id="{A00038C8-E235-4940-88D7-535B68A2835F}"/>
+                <a16:creationId xmlns:a16="http://schemas.microsoft.com/office/drawing/2014/main" id="{73852193-8629-4134-A859-59985C307E48}"/>
               </a:ext>
             </a:extLst>
           </p:cNvPr>
@@ -7621,7 +7929,7 @@
           <p:cNvPr id="5" name="">
             <a:extLst xmlns:a="http://schemas.openxmlformats.org/drawingml/2006/main">
               <a:ext uri="{FF2B5EF4-FFF2-40B4-BE49-F238E27FC236}">
-                <a16:creationId xmlns:a16="http://schemas.microsoft.com/office/drawing/2014/main" id="{7689885F-742F-462D-B9CA-4D6822124089}"/>
+                <a16:creationId xmlns:a16="http://schemas.microsoft.com/office/drawing/2014/main" id="{EB4CA60C-BC04-49D1-B3FA-55644FB26F4A}"/>
               </a:ext>
             </a:extLst>
           </p:cNvPr>
@@ -7938,7 +8246,7 @@
           <p:cNvPr id="7" name="">
             <a:extLst xmlns:a="http://schemas.openxmlformats.org/drawingml/2006/main">
               <a:ext uri="{FF2B5EF4-FFF2-40B4-BE49-F238E27FC236}">
-                <a16:creationId xmlns:a16="http://schemas.microsoft.com/office/drawing/2014/main" id="{BF843EBF-6403-48EC-834D-1A46D45A7E3E}"/>
+                <a16:creationId xmlns:a16="http://schemas.microsoft.com/office/drawing/2014/main" id="{CDBF833A-DC38-416E-ABAA-F9F66C42BFB3}"/>
               </a:ext>
             </a:extLst>
           </p:cNvPr>
@@ -7993,7 +8301,7 @@
     </p:spTree>
     <p:extLst>
       <p:ext uri="{BB962C8B-B14F-4D97-AF65-F5344CB8AC3E}">
-        <p14:creationId xmlns:p14="http://schemas.microsoft.com/office/powerpoint/2010/main" val="1410649185"/>
+        <p14:creationId xmlns:p14="http://schemas.microsoft.com/office/powerpoint/2010/main" val="390226476"/>
       </p:ext>
     </p:extLst>
   </p:cSld>
@@ -8024,7 +8332,7 @@
           <p:cNvPr id="9" name="">
             <a:extLst xmlns:a="http://schemas.openxmlformats.org/drawingml/2006/main">
               <a:ext uri="{FF2B5EF4-FFF2-40B4-BE49-F238E27FC236}">
-                <a16:creationId xmlns:a16="http://schemas.microsoft.com/office/drawing/2014/main" id="{96756610-F14B-4DEA-AB55-046242F3FB37}"/>
+                <a16:creationId xmlns:a16="http://schemas.microsoft.com/office/drawing/2014/main" id="{51AD2864-D54B-4617-A352-0A292FE35666}"/>
               </a:ext>
             </a:extLst>
           </p:cNvPr>
@@ -8081,7 +8389,7 @@
           <p:cNvPr id="2" name="">
             <a:extLst xmlns:a="http://schemas.openxmlformats.org/drawingml/2006/main">
               <a:ext uri="{FF2B5EF4-FFF2-40B4-BE49-F238E27FC236}">
-                <a16:creationId xmlns:a16="http://schemas.microsoft.com/office/drawing/2014/main" id="{5D3E8BFD-B1BF-404C-B909-93DF78EF964F}"/>
+                <a16:creationId xmlns:a16="http://schemas.microsoft.com/office/drawing/2014/main" id="{C8A5E2C7-3EE8-4B6B-9628-A4B8651082A2}"/>
               </a:ext>
             </a:extLst>
           </p:cNvPr>
@@ -8138,7 +8446,7 @@
           <p:cNvPr id="3" name="">
             <a:extLst xmlns:a="http://schemas.openxmlformats.org/drawingml/2006/main">
               <a:ext uri="{FF2B5EF4-FFF2-40B4-BE49-F238E27FC236}">
-                <a16:creationId xmlns:a16="http://schemas.microsoft.com/office/drawing/2014/main" id="{2EAF131E-26DF-4C5D-A1E9-ADC7AD040A04}"/>
+                <a16:creationId xmlns:a16="http://schemas.microsoft.com/office/drawing/2014/main" id="{C12BA85A-9473-48DC-84C4-5C473BC0A764}"/>
               </a:ext>
             </a:extLst>
           </p:cNvPr>
@@ -8174,8 +8482,8 @@
           <p:nvPr/>
         </p:nvPicPr>
         <p:blipFill>
-          <a:blip xmlns:r="http://schemas.openxmlformats.org/officeDocument/2006/relationships" xmlns:a="http://schemas.openxmlformats.org/drawingml/2006/main" r:embed="R966e1384c6d140cc"/>
-          <a:srcRect xmlns:a="http://schemas.openxmlformats.org/drawingml/2006/main" l="3125" t="0" r="3125" b="0"/>
+          <a:blip xmlns:r="http://schemas.openxmlformats.org/officeDocument/2006/relationships" xmlns:a="http://schemas.openxmlformats.org/drawingml/2006/main" r:embed="Ref90e5d8794f4bc6"/>
+          <a:srcRect xmlns:a="http://schemas.openxmlformats.org/drawingml/2006/main" l="0" t="25610" r="0" b="25610"/>
           <a:stretch xmlns:a="http://schemas.openxmlformats.org/drawingml/2006/main">
             <a:fillRect l="0" t="0" r="0" b="0"/>
           </a:stretch>
@@ -8199,8 +8507,8 @@
           <p:nvPr/>
         </p:nvPicPr>
         <p:blipFill>
-          <a:blip xmlns:r="http://schemas.openxmlformats.org/officeDocument/2006/relationships" xmlns:a="http://schemas.openxmlformats.org/drawingml/2006/main" r:embed="Rac6f599196374957"/>
-          <a:srcRect xmlns:a="http://schemas.openxmlformats.org/drawingml/2006/main" l="3125" t="0" r="3125" b="0"/>
+          <a:blip xmlns:r="http://schemas.openxmlformats.org/officeDocument/2006/relationships" xmlns:a="http://schemas.openxmlformats.org/drawingml/2006/main" r:embed="R8b8c732970ad447f"/>
+          <a:srcRect xmlns:a="http://schemas.openxmlformats.org/drawingml/2006/main" l="0" t="25610" r="0" b="25610"/>
           <a:stretch xmlns:a="http://schemas.openxmlformats.org/drawingml/2006/main">
             <a:fillRect l="0" t="0" r="0" b="0"/>
           </a:stretch>
@@ -8220,7 +8528,7 @@
           <p:cNvPr id="6" name="">
             <a:extLst xmlns:a="http://schemas.openxmlformats.org/drawingml/2006/main">
               <a:ext uri="{FF2B5EF4-FFF2-40B4-BE49-F238E27FC236}">
-                <a16:creationId xmlns:a16="http://schemas.microsoft.com/office/drawing/2014/main" id="{EE36125D-DD61-4385-91C2-038F0BD69671}"/>
+                <a16:creationId xmlns:a16="http://schemas.microsoft.com/office/drawing/2014/main" id="{8627EED0-26A6-46B8-BF9A-2F069EC70037}"/>
               </a:ext>
             </a:extLst>
           </p:cNvPr>
@@ -8277,7 +8585,7 @@
           <p:cNvPr id="7" name="">
             <a:extLst xmlns:a="http://schemas.openxmlformats.org/drawingml/2006/main">
               <a:ext uri="{FF2B5EF4-FFF2-40B4-BE49-F238E27FC236}">
-                <a16:creationId xmlns:a16="http://schemas.microsoft.com/office/drawing/2014/main" id="{A7D2B999-0FC9-49DC-B97C-7166EBB3C9E6}"/>
+                <a16:creationId xmlns:a16="http://schemas.microsoft.com/office/drawing/2014/main" id="{2E16AD84-9452-4005-BFB9-8C72356E7A0F}"/>
               </a:ext>
             </a:extLst>
           </p:cNvPr>
@@ -8334,7 +8642,7 @@
           <p:cNvPr id="8" name="">
             <a:extLst xmlns:a="http://schemas.openxmlformats.org/drawingml/2006/main">
               <a:ext uri="{FF2B5EF4-FFF2-40B4-BE49-F238E27FC236}">
-                <a16:creationId xmlns:a16="http://schemas.microsoft.com/office/drawing/2014/main" id="{EDFD774E-FFCF-4B48-BE77-E9638B836878}"/>
+                <a16:creationId xmlns:a16="http://schemas.microsoft.com/office/drawing/2014/main" id="{408168AD-84A6-4B75-B2D9-5E3E209E589C}"/>
               </a:ext>
             </a:extLst>
           </p:cNvPr>
@@ -8389,7 +8697,7 @@
     </p:spTree>
     <p:extLst>
       <p:ext uri="{BB962C8B-B14F-4D97-AF65-F5344CB8AC3E}">
-        <p14:creationId xmlns:p14="http://schemas.microsoft.com/office/powerpoint/2010/main" val="813372836"/>
+        <p14:creationId xmlns:p14="http://schemas.microsoft.com/office/powerpoint/2010/main" val="1296236394"/>
       </p:ext>
     </p:extLst>
   </p:cSld>
@@ -8420,7 +8728,7 @@
           <p:cNvPr id="10" name="">
             <a:extLst xmlns:a="http://schemas.openxmlformats.org/drawingml/2006/main">
               <a:ext uri="{FF2B5EF4-FFF2-40B4-BE49-F238E27FC236}">
-                <a16:creationId xmlns:a16="http://schemas.microsoft.com/office/drawing/2014/main" id="{911B634C-21D1-45FF-880C-87A2570BE926}"/>
+                <a16:creationId xmlns:a16="http://schemas.microsoft.com/office/drawing/2014/main" id="{372A67F3-6A73-497A-AAD3-56336345AA18}"/>
               </a:ext>
             </a:extLst>
           </p:cNvPr>
@@ -8477,7 +8785,7 @@
           <p:cNvPr id="2" name="">
             <a:extLst xmlns:a="http://schemas.openxmlformats.org/drawingml/2006/main">
               <a:ext uri="{FF2B5EF4-FFF2-40B4-BE49-F238E27FC236}">
-                <a16:creationId xmlns:a16="http://schemas.microsoft.com/office/drawing/2014/main" id="{4827633E-A4E9-46BE-84E2-79C8150E87AB}"/>
+                <a16:creationId xmlns:a16="http://schemas.microsoft.com/office/drawing/2014/main" id="{C9A97C54-0CE7-4C23-AC23-B6E8290BFF83}"/>
               </a:ext>
             </a:extLst>
           </p:cNvPr>
@@ -8534,7 +8842,7 @@
           <p:cNvPr id="3" name="">
             <a:extLst xmlns:a="http://schemas.openxmlformats.org/drawingml/2006/main">
               <a:ext uri="{FF2B5EF4-FFF2-40B4-BE49-F238E27FC236}">
-                <a16:creationId xmlns:a16="http://schemas.microsoft.com/office/drawing/2014/main" id="{241B93DC-FC94-4BF0-864C-B0BBE52FF892}"/>
+                <a16:creationId xmlns:a16="http://schemas.microsoft.com/office/drawing/2014/main" id="{EAA7F9D8-2592-457D-A99C-16B3199CC376}"/>
               </a:ext>
             </a:extLst>
           </p:cNvPr>
@@ -8573,7 +8881,7 @@
         </p:xfrm>
         <a:graphic xmlns:a="http://schemas.openxmlformats.org/drawingml/2006/main">
           <a:graphicData uri="http://schemas.openxmlformats.org/drawingml/2006/chart">
-            <c:chart xmlns:r="http://schemas.openxmlformats.org/officeDocument/2006/relationships" xmlns:c="http://schemas.openxmlformats.org/drawingml/2006/chart" r:id="R0f3f6779077647fc"/>
+            <c:chart xmlns:r="http://schemas.openxmlformats.org/officeDocument/2006/relationships" xmlns:c="http://schemas.openxmlformats.org/drawingml/2006/chart" r:id="R7caf252d0921414d"/>
           </a:graphicData>
         </a:graphic>
       </p:graphicFrame>
@@ -8582,7 +8890,7 @@
           <p:cNvPr id="5" name="">
             <a:extLst xmlns:a="http://schemas.openxmlformats.org/drawingml/2006/main">
               <a:ext uri="{FF2B5EF4-FFF2-40B4-BE49-F238E27FC236}">
-                <a16:creationId xmlns:a16="http://schemas.microsoft.com/office/drawing/2014/main" id="{02E1A49E-89F5-42DF-8BD8-2DD4378870DF}"/>
+                <a16:creationId xmlns:a16="http://schemas.microsoft.com/office/drawing/2014/main" id="{5E897325-4DB0-4FAC-99B6-9C5E72561E4D}"/>
               </a:ext>
             </a:extLst>
           </p:cNvPr>
@@ -8639,7 +8947,7 @@
           <p:cNvPr id="6" name="">
             <a:extLst xmlns:a="http://schemas.openxmlformats.org/drawingml/2006/main">
               <a:ext uri="{FF2B5EF4-FFF2-40B4-BE49-F238E27FC236}">
-                <a16:creationId xmlns:a16="http://schemas.microsoft.com/office/drawing/2014/main" id="{8F1EF6D3-EC37-48D8-AA21-0A874B97B4E5}"/>
+                <a16:creationId xmlns:a16="http://schemas.microsoft.com/office/drawing/2014/main" id="{F110888F-F837-475F-AFB7-A77B4218ED7E}"/>
               </a:ext>
             </a:extLst>
           </p:cNvPr>
@@ -8719,7 +9027,7 @@
           <p:cNvPr id="7" name="">
             <a:extLst xmlns:a="http://schemas.openxmlformats.org/drawingml/2006/main">
               <a:ext uri="{FF2B5EF4-FFF2-40B4-BE49-F238E27FC236}">
-                <a16:creationId xmlns:a16="http://schemas.microsoft.com/office/drawing/2014/main" id="{037C869E-2E1D-4D24-849C-133982D750B8}"/>
+                <a16:creationId xmlns:a16="http://schemas.microsoft.com/office/drawing/2014/main" id="{61116621-3026-44E2-8828-DF49327DD750}"/>
               </a:ext>
             </a:extLst>
           </p:cNvPr>
@@ -8776,7 +9084,7 @@
           <p:cNvPr id="8" name="">
             <a:extLst xmlns:a="http://schemas.openxmlformats.org/drawingml/2006/main">
               <a:ext uri="{FF2B5EF4-FFF2-40B4-BE49-F238E27FC236}">
-                <a16:creationId xmlns:a16="http://schemas.microsoft.com/office/drawing/2014/main" id="{F0D73FB3-F4F7-4BC3-A94A-5C51CB9A277A}"/>
+                <a16:creationId xmlns:a16="http://schemas.microsoft.com/office/drawing/2014/main" id="{8E4182B8-4C12-4103-84EA-951BBF471798}"/>
               </a:ext>
             </a:extLst>
           </p:cNvPr>
@@ -8833,7 +9141,7 @@
           <p:cNvPr id="9" name="">
             <a:extLst xmlns:a="http://schemas.openxmlformats.org/drawingml/2006/main">
               <a:ext uri="{FF2B5EF4-FFF2-40B4-BE49-F238E27FC236}">
-                <a16:creationId xmlns:a16="http://schemas.microsoft.com/office/drawing/2014/main" id="{81EFA811-92FD-4F9D-8821-03D551FA6104}"/>
+                <a16:creationId xmlns:a16="http://schemas.microsoft.com/office/drawing/2014/main" id="{CCB93C2F-E561-4C7C-9D93-EAD9AFE8DD76}"/>
               </a:ext>
             </a:extLst>
           </p:cNvPr>
@@ -8888,7 +9196,7 @@
     </p:spTree>
     <p:extLst>
       <p:ext uri="{BB962C8B-B14F-4D97-AF65-F5344CB8AC3E}">
-        <p14:creationId xmlns:p14="http://schemas.microsoft.com/office/powerpoint/2010/main" val="1680875263"/>
+        <p14:creationId xmlns:p14="http://schemas.microsoft.com/office/powerpoint/2010/main" val="1084534580"/>
       </p:ext>
     </p:extLst>
   </p:cSld>

</xml_diff>